<commit_message>
Update PPTX scripts and regenerate slides for model_name/image/separator features
- make_manual_pptx.py: Slide 4 (Top画面) — プロジェクト一覧にモデル名/プロジェクト名の横並び表示を反映
- make_manual_pptx.py: Slide 5 (プロジェクト設定) — モデル名・サムネイル画像フィールドを追加
- make_manual_pptx.py: Slide 6 (Scheduleヘッダー) — サムネイル+「モデル名 / PJ名」形式のヘッダー模示を追加
- make_manual_pptx.py: Slide 10 (比較表示) — セパレーター行の説明を追加
- make_proposal_pptx.py: Slide 4 (提案概要) — モデル名分類・サムネイル・比較セパレーターを主要機能に追加
- docs/*.pptx: 上記スクリプトで再生成

Co-Authored-By: Claude Sonnet 4.6 <noreply@anthropic.com>
</commit_message>
<xml_diff>
--- a/docs/opeSchedule_manual.pptx
+++ b/docs/opeSchedule_manual.pptx
@@ -4267,7 +4267,7 @@
         <p:spPr>
           <a:xfrm>
             <a:off x="365760" y="2606040"/>
-            <a:ext cx="5486400" cy="1554480"/>
+            <a:ext cx="5486400" cy="1737360"/>
           </a:xfrm>
           <a:prstGeom prst="rect">
             <a:avLst/>
@@ -4310,7 +4310,7 @@
         <p:spPr>
           <a:xfrm>
             <a:off x="475488" y="2651760"/>
-            <a:ext cx="5266944" cy="1417320"/>
+            <a:ext cx="5266944" cy="1600199"/>
           </a:xfrm>
           <a:prstGeom prst="rect">
             <a:avLst/>
@@ -4379,7 +4379,22 @@
                   <a:srgbClr val="2C3E50"/>
                 </a:solidFill>
               </a:rPr>
-              <a:t>④ ガントチャートに全 PJ のタスクが並んで表示</a:t>
+              <a:t>④ プロジェクト間にセパレーター行が挿入され</a:t>
+            </a:r>
+          </a:p>
+          <a:p>
+            <a:pPr>
+              <a:spcBef>
+                <a:spcPts val="400"/>
+              </a:spcBef>
+            </a:pPr>
+            <a:r>
+              <a:rPr sz="1200">
+                <a:solidFill>
+                  <a:srgbClr val="2C3E50"/>
+                </a:solidFill>
+              </a:rPr>
+              <a:t>   全 PJ のタスクがまとめて表示される</a:t>
             </a:r>
           </a:p>
         </p:txBody>
@@ -4392,7 +4407,571 @@
         </p:nvSpPr>
         <p:spPr>
           <a:xfrm>
-            <a:off x="365760" y="4251960"/>
+            <a:off x="365760" y="4434840"/>
+            <a:ext cx="5486400" cy="1051560"/>
+          </a:xfrm>
+          <a:prstGeom prst="rect">
+            <a:avLst/>
+          </a:prstGeom>
+          <a:solidFill>
+            <a:srgbClr val="EAF4FB"/>
+          </a:solidFill>
+          <a:ln>
+            <a:noFill/>
+          </a:ln>
+        </p:spPr>
+        <p:style>
+          <a:lnRef idx="1">
+            <a:schemeClr val="accent1"/>
+          </a:lnRef>
+          <a:fillRef idx="3">
+            <a:schemeClr val="accent1"/>
+          </a:fillRef>
+          <a:effectRef idx="2">
+            <a:schemeClr val="accent1"/>
+          </a:effectRef>
+          <a:fontRef idx="minor">
+            <a:schemeClr val="lt1"/>
+          </a:fontRef>
+        </p:style>
+        <p:txBody>
+          <a:bodyPr rtlCol="0" anchor="ctr"/>
+          <a:lstStyle/>
+          <a:p>
+            <a:pPr algn="ctr"/>
+          </a:p>
+        </p:txBody>
+      </p:sp>
+      <p:sp>
+        <p:nvSpPr>
+          <p:cNvPr id="16" name="TextBox 15"/>
+          <p:cNvSpPr txBox="1"/>
+          <p:nvPr/>
+        </p:nvSpPr>
+        <p:spPr>
+          <a:xfrm>
+            <a:off x="457200" y="4462272"/>
+            <a:ext cx="5303520" cy="320040"/>
+          </a:xfrm>
+          <a:prstGeom prst="rect">
+            <a:avLst/>
+          </a:prstGeom>
+          <a:noFill/>
+        </p:spPr>
+        <p:txBody>
+          <a:bodyPr wrap="square">
+            <a:spAutoFit/>
+          </a:bodyPr>
+          <a:lstStyle/>
+          <a:p>
+            <a:pPr algn="l"/>
+            <a:r>
+              <a:rPr sz="1200" b="1" i="0">
+                <a:solidFill>
+                  <a:srgbClr val="4A90D9"/>
+                </a:solidFill>
+              </a:rPr>
+              <a:t>📌  セパレーター行</a:t>
+            </a:r>
+          </a:p>
+        </p:txBody>
+      </p:sp>
+      <p:sp>
+        <p:nvSpPr>
+          <p:cNvPr id="17" name="TextBox 16"/>
+          <p:cNvSpPr txBox="1"/>
+          <p:nvPr/>
+        </p:nvSpPr>
+        <p:spPr>
+          <a:xfrm>
+            <a:off x="457200" y="4800600"/>
+            <a:ext cx="5303520" cy="640080"/>
+          </a:xfrm>
+          <a:prstGeom prst="rect">
+            <a:avLst/>
+          </a:prstGeom>
+          <a:noFill/>
+        </p:spPr>
+        <p:txBody>
+          <a:bodyPr wrap="square">
+            <a:spAutoFit/>
+          </a:bodyPr>
+          <a:lstStyle/>
+          <a:p>
+            <a:pPr algn="l"/>
+            <a:r>
+              <a:rPr sz="1100" b="0" i="0">
+                <a:solidFill>
+                  <a:srgbClr val="2C3E50"/>
+                </a:solidFill>
+              </a:rPr>
+              <a:t>プロジェクトとプロジェクトの間に
+プロジェクト名を示す区切り行が自動挿入されます。
+モデル名 / プロジェクト名 の形式で識別可能。</a:t>
+            </a:r>
+          </a:p>
+        </p:txBody>
+      </p:sp>
+      <p:sp>
+        <p:nvSpPr>
+          <p:cNvPr id="18" name="Rectangle 17"/>
+          <p:cNvSpPr/>
+          <p:nvPr/>
+        </p:nvSpPr>
+        <p:spPr>
+          <a:xfrm>
+            <a:off x="365760" y="5577840"/>
+            <a:ext cx="5486400" cy="960120"/>
+          </a:xfrm>
+          <a:prstGeom prst="rect">
+            <a:avLst/>
+          </a:prstGeom>
+          <a:solidFill>
+            <a:srgbClr val="FFF3CD"/>
+          </a:solidFill>
+          <a:ln>
+            <a:noFill/>
+          </a:ln>
+        </p:spPr>
+        <p:style>
+          <a:lnRef idx="1">
+            <a:schemeClr val="accent1"/>
+          </a:lnRef>
+          <a:fillRef idx="3">
+            <a:schemeClr val="accent1"/>
+          </a:fillRef>
+          <a:effectRef idx="2">
+            <a:schemeClr val="accent1"/>
+          </a:effectRef>
+          <a:fontRef idx="minor">
+            <a:schemeClr val="lt1"/>
+          </a:fontRef>
+        </p:style>
+        <p:txBody>
+          <a:bodyPr rtlCol="0" anchor="ctr"/>
+          <a:lstStyle/>
+          <a:p>
+            <a:pPr algn="ctr"/>
+          </a:p>
+        </p:txBody>
+      </p:sp>
+      <p:sp>
+        <p:nvSpPr>
+          <p:cNvPr id="19" name="TextBox 18"/>
+          <p:cNvSpPr txBox="1"/>
+          <p:nvPr/>
+        </p:nvSpPr>
+        <p:spPr>
+          <a:xfrm>
+            <a:off x="457200" y="5605272"/>
+            <a:ext cx="5394960" cy="320040"/>
+          </a:xfrm>
+          <a:prstGeom prst="rect">
+            <a:avLst/>
+          </a:prstGeom>
+          <a:noFill/>
+        </p:spPr>
+        <p:txBody>
+          <a:bodyPr wrap="square">
+            <a:spAutoFit/>
+          </a:bodyPr>
+          <a:lstStyle/>
+          <a:p>
+            <a:pPr algn="l"/>
+            <a:r>
+              <a:rPr sz="1200" b="1" i="0">
+                <a:solidFill>
+                  <a:srgbClr val="E74C3C"/>
+                </a:solidFill>
+              </a:rPr>
+              <a:t>⚠  比較モードの制限</a:t>
+            </a:r>
+          </a:p>
+        </p:txBody>
+      </p:sp>
+      <p:sp>
+        <p:nvSpPr>
+          <p:cNvPr id="20" name="TextBox 19"/>
+          <p:cNvSpPr txBox="1"/>
+          <p:nvPr/>
+        </p:nvSpPr>
+        <p:spPr>
+          <a:xfrm>
+            <a:off x="457200" y="5943600"/>
+            <a:ext cx="5394960" cy="566928"/>
+          </a:xfrm>
+          <a:prstGeom prst="rect">
+            <a:avLst/>
+          </a:prstGeom>
+          <a:noFill/>
+        </p:spPr>
+        <p:txBody>
+          <a:bodyPr wrap="square">
+            <a:spAutoFit/>
+          </a:bodyPr>
+          <a:lstStyle/>
+          <a:p>
+            <a:pPr algn="l"/>
+            <a:r>
+              <a:rPr sz="1100" b="0" i="0">
+                <a:solidFill>
+                  <a:srgbClr val="2C3E50"/>
+                </a:solidFill>
+              </a:rPr>
+              <a:t>・タスク追加・Export ボタン非表示
+・タスク詳細は読み取り専用（編集不可）
+・ドラッグ・クリティカルパス・依存矢印無効</a:t>
+            </a:r>
+          </a:p>
+        </p:txBody>
+      </p:sp>
+      <p:sp>
+        <p:nvSpPr>
+          <p:cNvPr id="21" name="Rectangle 20"/>
+          <p:cNvSpPr/>
+          <p:nvPr/>
+        </p:nvSpPr>
+        <p:spPr>
+          <a:xfrm>
+            <a:off x="6217920" y="1737360"/>
+            <a:ext cx="5669280" cy="4846320"/>
+          </a:xfrm>
+          <a:prstGeom prst="rect">
+            <a:avLst/>
+          </a:prstGeom>
+          <a:solidFill>
+            <a:srgbClr val="FFFFFF"/>
+          </a:solidFill>
+          <a:ln>
+            <a:noFill/>
+          </a:ln>
+        </p:spPr>
+        <p:style>
+          <a:lnRef idx="1">
+            <a:schemeClr val="accent1"/>
+          </a:lnRef>
+          <a:fillRef idx="3">
+            <a:schemeClr val="accent1"/>
+          </a:fillRef>
+          <a:effectRef idx="2">
+            <a:schemeClr val="accent1"/>
+          </a:effectRef>
+          <a:fontRef idx="minor">
+            <a:schemeClr val="lt1"/>
+          </a:fontRef>
+        </p:style>
+        <p:txBody>
+          <a:bodyPr rtlCol="0" anchor="ctr"/>
+          <a:lstStyle/>
+          <a:p>
+            <a:pPr algn="ctr"/>
+          </a:p>
+        </p:txBody>
+      </p:sp>
+      <p:sp>
+        <p:nvSpPr>
+          <p:cNvPr id="22" name="Rectangle 21"/>
+          <p:cNvSpPr/>
+          <p:nvPr/>
+        </p:nvSpPr>
+        <p:spPr>
+          <a:xfrm>
+            <a:off x="6217920" y="1737360"/>
+            <a:ext cx="5669280" cy="411480"/>
+          </a:xfrm>
+          <a:prstGeom prst="rect">
+            <a:avLst/>
+          </a:prstGeom>
+          <a:solidFill>
+            <a:srgbClr val="8E44AD"/>
+          </a:solidFill>
+          <a:ln>
+            <a:noFill/>
+          </a:ln>
+        </p:spPr>
+        <p:style>
+          <a:lnRef idx="1">
+            <a:schemeClr val="accent1"/>
+          </a:lnRef>
+          <a:fillRef idx="3">
+            <a:schemeClr val="accent1"/>
+          </a:fillRef>
+          <a:effectRef idx="2">
+            <a:schemeClr val="accent1"/>
+          </a:effectRef>
+          <a:fontRef idx="minor">
+            <a:schemeClr val="lt1"/>
+          </a:fontRef>
+        </p:style>
+        <p:txBody>
+          <a:bodyPr rtlCol="0" anchor="ctr"/>
+          <a:lstStyle/>
+          <a:p>
+            <a:pPr algn="ctr"/>
+          </a:p>
+        </p:txBody>
+      </p:sp>
+      <p:sp>
+        <p:nvSpPr>
+          <p:cNvPr id="23" name="TextBox 22"/>
+          <p:cNvSpPr txBox="1"/>
+          <p:nvPr/>
+        </p:nvSpPr>
+        <p:spPr>
+          <a:xfrm>
+            <a:off x="6309360" y="1764792"/>
+            <a:ext cx="5486400" cy="365760"/>
+          </a:xfrm>
+          <a:prstGeom prst="rect">
+            <a:avLst/>
+          </a:prstGeom>
+          <a:noFill/>
+        </p:spPr>
+        <p:txBody>
+          <a:bodyPr wrap="square">
+            <a:spAutoFit/>
+          </a:bodyPr>
+          <a:lstStyle/>
+          <a:p>
+            <a:pPr algn="l"/>
+            <a:r>
+              <a:rPr sz="1400" b="1" i="0">
+                <a:solidFill>
+                  <a:srgbClr val="FFFFFF"/>
+                </a:solidFill>
+              </a:rPr>
+              <a:t>🔍  大項目フィルター表示</a:t>
+            </a:r>
+          </a:p>
+        </p:txBody>
+      </p:sp>
+      <p:sp>
+        <p:nvSpPr>
+          <p:cNvPr id="24" name="Rectangle 23"/>
+          <p:cNvSpPr/>
+          <p:nvPr/>
+        </p:nvSpPr>
+        <p:spPr>
+          <a:xfrm>
+            <a:off x="6309360" y="2240280"/>
+            <a:ext cx="5486400" cy="365760"/>
+          </a:xfrm>
+          <a:prstGeom prst="rect">
+            <a:avLst/>
+          </a:prstGeom>
+          <a:solidFill>
+            <a:srgbClr val="8E44AD"/>
+          </a:solidFill>
+          <a:ln>
+            <a:noFill/>
+          </a:ln>
+        </p:spPr>
+        <p:style>
+          <a:lnRef idx="1">
+            <a:schemeClr val="accent1"/>
+          </a:lnRef>
+          <a:fillRef idx="3">
+            <a:schemeClr val="accent1"/>
+          </a:fillRef>
+          <a:effectRef idx="2">
+            <a:schemeClr val="accent1"/>
+          </a:effectRef>
+          <a:fontRef idx="minor">
+            <a:schemeClr val="lt1"/>
+          </a:fontRef>
+        </p:style>
+        <p:txBody>
+          <a:bodyPr rtlCol="0" anchor="ctr"/>
+          <a:lstStyle/>
+          <a:p>
+            <a:pPr algn="ctr"/>
+          </a:p>
+        </p:txBody>
+      </p:sp>
+      <p:sp>
+        <p:nvSpPr>
+          <p:cNvPr id="25" name="TextBox 24"/>
+          <p:cNvSpPr txBox="1"/>
+          <p:nvPr/>
+        </p:nvSpPr>
+        <p:spPr>
+          <a:xfrm>
+            <a:off x="6400800" y="2276856"/>
+            <a:ext cx="5303520" cy="320040"/>
+          </a:xfrm>
+          <a:prstGeom prst="rect">
+            <a:avLst/>
+          </a:prstGeom>
+          <a:noFill/>
+        </p:spPr>
+        <p:txBody>
+          <a:bodyPr wrap="square">
+            <a:spAutoFit/>
+          </a:bodyPr>
+          <a:lstStyle/>
+          <a:p>
+            <a:pPr algn="l"/>
+            <a:r>
+              <a:rPr sz="1300" b="1" i="0">
+                <a:solidFill>
+                  <a:srgbClr val="FFFFFF"/>
+                </a:solidFill>
+              </a:rPr>
+              <a:t>操作手順</a:t>
+            </a:r>
+          </a:p>
+        </p:txBody>
+      </p:sp>
+      <p:sp>
+        <p:nvSpPr>
+          <p:cNvPr id="26" name="Rectangle 25"/>
+          <p:cNvSpPr/>
+          <p:nvPr/>
+        </p:nvSpPr>
+        <p:spPr>
+          <a:xfrm>
+            <a:off x="6309360" y="2606040"/>
+            <a:ext cx="5486400" cy="1737360"/>
+          </a:xfrm>
+          <a:prstGeom prst="rect">
+            <a:avLst/>
+          </a:prstGeom>
+          <a:solidFill>
+            <a:srgbClr val="F5F6FA"/>
+          </a:solidFill>
+          <a:ln>
+            <a:noFill/>
+          </a:ln>
+        </p:spPr>
+        <p:style>
+          <a:lnRef idx="1">
+            <a:schemeClr val="accent1"/>
+          </a:lnRef>
+          <a:fillRef idx="3">
+            <a:schemeClr val="accent1"/>
+          </a:fillRef>
+          <a:effectRef idx="2">
+            <a:schemeClr val="accent1"/>
+          </a:effectRef>
+          <a:fontRef idx="minor">
+            <a:schemeClr val="lt1"/>
+          </a:fontRef>
+        </p:style>
+        <p:txBody>
+          <a:bodyPr rtlCol="0" anchor="ctr"/>
+          <a:lstStyle/>
+          <a:p>
+            <a:pPr algn="ctr"/>
+          </a:p>
+        </p:txBody>
+      </p:sp>
+      <p:sp>
+        <p:nvSpPr>
+          <p:cNvPr id="27" name="TextBox 26"/>
+          <p:cNvSpPr txBox="1"/>
+          <p:nvPr/>
+        </p:nvSpPr>
+        <p:spPr>
+          <a:xfrm>
+            <a:off x="6419088" y="2651760"/>
+            <a:ext cx="5266944" cy="1600199"/>
+          </a:xfrm>
+          <a:prstGeom prst="rect">
+            <a:avLst/>
+          </a:prstGeom>
+          <a:noFill/>
+        </p:spPr>
+        <p:txBody>
+          <a:bodyPr wrap="square">
+            <a:spAutoFit/>
+          </a:bodyPr>
+          <a:lstStyle/>
+          <a:p>
+            <a:pPr>
+              <a:spcBef>
+                <a:spcPts val="400"/>
+              </a:spcBef>
+            </a:pPr>
+            <a:r>
+              <a:rPr sz="1200">
+                <a:solidFill>
+                  <a:srgbClr val="2C3E50"/>
+                </a:solidFill>
+              </a:rPr>
+              <a:t>① Top 画面左サイドバー「大項目フィルター」を展開</a:t>
+            </a:r>
+          </a:p>
+          <a:p>
+            <a:pPr>
+              <a:spcBef>
+                <a:spcPts val="400"/>
+              </a:spcBef>
+            </a:pPr>
+            <a:r>
+              <a:rPr sz="1200">
+                <a:solidFill>
+                  <a:srgbClr val="2C3E50"/>
+                </a:solidFill>
+              </a:rPr>
+              <a:t>② 表示したい大項目をチェック（複数可）</a:t>
+            </a:r>
+          </a:p>
+          <a:p>
+            <a:pPr>
+              <a:spcBef>
+                <a:spcPts val="400"/>
+              </a:spcBef>
+            </a:pPr>
+            <a:r>
+              <a:rPr sz="1200">
+                <a:solidFill>
+                  <a:srgbClr val="2C3E50"/>
+                </a:solidFill>
+              </a:rPr>
+              <a:t>③ 対象プロジェクトをチェック</a:t>
+            </a:r>
+          </a:p>
+          <a:p>
+            <a:pPr>
+              <a:spcBef>
+                <a:spcPts val="400"/>
+              </a:spcBef>
+            </a:pPr>
+            <a:r>
+              <a:rPr sz="1200">
+                <a:solidFill>
+                  <a:srgbClr val="2C3E50"/>
+                </a:solidFill>
+              </a:rPr>
+              <a:t>④「フィルター表示」ボタンをクリック</a:t>
+            </a:r>
+          </a:p>
+          <a:p>
+            <a:pPr>
+              <a:spcBef>
+                <a:spcPts val="400"/>
+              </a:spcBef>
+            </a:pPr>
+            <a:r>
+              <a:rPr sz="1200">
+                <a:solidFill>
+                  <a:srgbClr val="2C3E50"/>
+                </a:solidFill>
+              </a:rPr>
+              <a:t>⑤ 選択した大項目のタスクのみが表示される</a:t>
+            </a:r>
+          </a:p>
+        </p:txBody>
+      </p:sp>
+      <p:sp>
+        <p:nvSpPr>
+          <p:cNvPr id="28" name="Rectangle 27"/>
+          <p:cNvSpPr/>
+          <p:nvPr/>
+        </p:nvSpPr>
+        <p:spPr>
+          <a:xfrm>
+            <a:off x="6309360" y="4434840"/>
             <a:ext cx="5486400" cy="365760"/>
           </a:xfrm>
           <a:prstGeom prst="rect">
@@ -4429,13 +5008,13 @@
       </p:sp>
       <p:sp>
         <p:nvSpPr>
-          <p:cNvPr id="16" name="TextBox 15"/>
-          <p:cNvSpPr txBox="1"/>
-          <p:nvPr/>
-        </p:nvSpPr>
-        <p:spPr>
-          <a:xfrm>
-            <a:off x="457200" y="4288536"/>
+          <p:cNvPr id="29" name="TextBox 28"/>
+          <p:cNvSpPr txBox="1"/>
+          <p:nvPr/>
+        </p:nvSpPr>
+        <p:spPr>
+          <a:xfrm>
+            <a:off x="6400800" y="4471416"/>
             <a:ext cx="5303520" cy="320040"/>
           </a:xfrm>
           <a:prstGeom prst="rect">
@@ -4463,13 +5042,13 @@
       </p:sp>
       <p:sp>
         <p:nvSpPr>
-          <p:cNvPr id="17" name="Rectangle 16"/>
+          <p:cNvPr id="30" name="Rectangle 29"/>
           <p:cNvSpPr/>
           <p:nvPr/>
         </p:nvSpPr>
         <p:spPr>
           <a:xfrm>
-            <a:off x="365760" y="4617720"/>
+            <a:off x="6309360" y="4800600"/>
             <a:ext cx="5486400" cy="548640"/>
           </a:xfrm>
           <a:prstGeom prst="rect">
@@ -4506,13 +5085,13 @@
       </p:sp>
       <p:sp>
         <p:nvSpPr>
-          <p:cNvPr id="18" name="TextBox 17"/>
-          <p:cNvSpPr txBox="1"/>
-          <p:nvPr/>
-        </p:nvSpPr>
-        <p:spPr>
-          <a:xfrm>
-            <a:off x="475488" y="4663440"/>
+          <p:cNvPr id="31" name="TextBox 30"/>
+          <p:cNvSpPr txBox="1"/>
+          <p:nvPr/>
+        </p:nvSpPr>
+        <p:spPr>
+          <a:xfrm>
+            <a:off x="6419088" y="4846320"/>
             <a:ext cx="5266944" cy="411479"/>
           </a:xfrm>
           <a:prstGeom prst="rect">
@@ -4537,7 +5116,7 @@
                   <a:srgbClr val="2C3E50"/>
                 </a:solidFill>
               </a:rPr>
-              <a:t>/schedule?projects=1,2,3</a:t>
+              <a:t>/schedule?projects=1&amp;projects=2</a:t>
             </a:r>
           </a:p>
           <a:p>
@@ -4552,630 +5131,6 @@
                   <a:srgbClr val="2C3E50"/>
                 </a:solidFill>
               </a:rPr>
-              <a:t>（カンマ区切りで project ID を指定）</a:t>
-            </a:r>
-          </a:p>
-        </p:txBody>
-      </p:sp>
-      <p:sp>
-        <p:nvSpPr>
-          <p:cNvPr id="19" name="Rectangle 18"/>
-          <p:cNvSpPr/>
-          <p:nvPr/>
-        </p:nvSpPr>
-        <p:spPr>
-          <a:xfrm>
-            <a:off x="365760" y="5257800"/>
-            <a:ext cx="5486400" cy="1188720"/>
-          </a:xfrm>
-          <a:prstGeom prst="rect">
-            <a:avLst/>
-          </a:prstGeom>
-          <a:solidFill>
-            <a:srgbClr val="FFF3CD"/>
-          </a:solidFill>
-          <a:ln>
-            <a:noFill/>
-          </a:ln>
-        </p:spPr>
-        <p:style>
-          <a:lnRef idx="1">
-            <a:schemeClr val="accent1"/>
-          </a:lnRef>
-          <a:fillRef idx="3">
-            <a:schemeClr val="accent1"/>
-          </a:fillRef>
-          <a:effectRef idx="2">
-            <a:schemeClr val="accent1"/>
-          </a:effectRef>
-          <a:fontRef idx="minor">
-            <a:schemeClr val="lt1"/>
-          </a:fontRef>
-        </p:style>
-        <p:txBody>
-          <a:bodyPr rtlCol="0" anchor="ctr"/>
-          <a:lstStyle/>
-          <a:p>
-            <a:pPr algn="ctr"/>
-          </a:p>
-        </p:txBody>
-      </p:sp>
-      <p:sp>
-        <p:nvSpPr>
-          <p:cNvPr id="20" name="TextBox 19"/>
-          <p:cNvSpPr txBox="1"/>
-          <p:nvPr/>
-        </p:nvSpPr>
-        <p:spPr>
-          <a:xfrm>
-            <a:off x="457200" y="5285232"/>
-            <a:ext cx="5394960" cy="320040"/>
-          </a:xfrm>
-          <a:prstGeom prst="rect">
-            <a:avLst/>
-          </a:prstGeom>
-          <a:noFill/>
-        </p:spPr>
-        <p:txBody>
-          <a:bodyPr wrap="square">
-            <a:spAutoFit/>
-          </a:bodyPr>
-          <a:lstStyle/>
-          <a:p>
-            <a:pPr algn="l"/>
-            <a:r>
-              <a:rPr sz="1200" b="1" i="0">
-                <a:solidFill>
-                  <a:srgbClr val="E74C3C"/>
-                </a:solidFill>
-              </a:rPr>
-              <a:t>⚠  比較モードの制限</a:t>
-            </a:r>
-          </a:p>
-        </p:txBody>
-      </p:sp>
-      <p:sp>
-        <p:nvSpPr>
-          <p:cNvPr id="21" name="TextBox 20"/>
-          <p:cNvSpPr txBox="1"/>
-          <p:nvPr/>
-        </p:nvSpPr>
-        <p:spPr>
-          <a:xfrm>
-            <a:off x="457200" y="5632704"/>
-            <a:ext cx="5394960" cy="777240"/>
-          </a:xfrm>
-          <a:prstGeom prst="rect">
-            <a:avLst/>
-          </a:prstGeom>
-          <a:noFill/>
-        </p:spPr>
-        <p:txBody>
-          <a:bodyPr wrap="square">
-            <a:spAutoFit/>
-          </a:bodyPr>
-          <a:lstStyle/>
-          <a:p>
-            <a:pPr algn="l"/>
-            <a:r>
-              <a:rPr sz="1100" b="0" i="0">
-                <a:solidFill>
-                  <a:srgbClr val="2C3E50"/>
-                </a:solidFill>
-              </a:rPr>
-              <a:t>・タスク追加・Export ボタン非表示
-・タスク詳細は読み取り専用（編集不可）
-・ドラッグ・クリティカルパス・依存矢印無効</a:t>
-            </a:r>
-          </a:p>
-        </p:txBody>
-      </p:sp>
-      <p:sp>
-        <p:nvSpPr>
-          <p:cNvPr id="22" name="Rectangle 21"/>
-          <p:cNvSpPr/>
-          <p:nvPr/>
-        </p:nvSpPr>
-        <p:spPr>
-          <a:xfrm>
-            <a:off x="6217920" y="1737360"/>
-            <a:ext cx="5669280" cy="4846320"/>
-          </a:xfrm>
-          <a:prstGeom prst="rect">
-            <a:avLst/>
-          </a:prstGeom>
-          <a:solidFill>
-            <a:srgbClr val="FFFFFF"/>
-          </a:solidFill>
-          <a:ln>
-            <a:noFill/>
-          </a:ln>
-        </p:spPr>
-        <p:style>
-          <a:lnRef idx="1">
-            <a:schemeClr val="accent1"/>
-          </a:lnRef>
-          <a:fillRef idx="3">
-            <a:schemeClr val="accent1"/>
-          </a:fillRef>
-          <a:effectRef idx="2">
-            <a:schemeClr val="accent1"/>
-          </a:effectRef>
-          <a:fontRef idx="minor">
-            <a:schemeClr val="lt1"/>
-          </a:fontRef>
-        </p:style>
-        <p:txBody>
-          <a:bodyPr rtlCol="0" anchor="ctr"/>
-          <a:lstStyle/>
-          <a:p>
-            <a:pPr algn="ctr"/>
-          </a:p>
-        </p:txBody>
-      </p:sp>
-      <p:sp>
-        <p:nvSpPr>
-          <p:cNvPr id="23" name="Rectangle 22"/>
-          <p:cNvSpPr/>
-          <p:nvPr/>
-        </p:nvSpPr>
-        <p:spPr>
-          <a:xfrm>
-            <a:off x="6217920" y="1737360"/>
-            <a:ext cx="5669280" cy="411480"/>
-          </a:xfrm>
-          <a:prstGeom prst="rect">
-            <a:avLst/>
-          </a:prstGeom>
-          <a:solidFill>
-            <a:srgbClr val="8E44AD"/>
-          </a:solidFill>
-          <a:ln>
-            <a:noFill/>
-          </a:ln>
-        </p:spPr>
-        <p:style>
-          <a:lnRef idx="1">
-            <a:schemeClr val="accent1"/>
-          </a:lnRef>
-          <a:fillRef idx="3">
-            <a:schemeClr val="accent1"/>
-          </a:fillRef>
-          <a:effectRef idx="2">
-            <a:schemeClr val="accent1"/>
-          </a:effectRef>
-          <a:fontRef idx="minor">
-            <a:schemeClr val="lt1"/>
-          </a:fontRef>
-        </p:style>
-        <p:txBody>
-          <a:bodyPr rtlCol="0" anchor="ctr"/>
-          <a:lstStyle/>
-          <a:p>
-            <a:pPr algn="ctr"/>
-          </a:p>
-        </p:txBody>
-      </p:sp>
-      <p:sp>
-        <p:nvSpPr>
-          <p:cNvPr id="24" name="TextBox 23"/>
-          <p:cNvSpPr txBox="1"/>
-          <p:nvPr/>
-        </p:nvSpPr>
-        <p:spPr>
-          <a:xfrm>
-            <a:off x="6309360" y="1764792"/>
-            <a:ext cx="5486400" cy="365760"/>
-          </a:xfrm>
-          <a:prstGeom prst="rect">
-            <a:avLst/>
-          </a:prstGeom>
-          <a:noFill/>
-        </p:spPr>
-        <p:txBody>
-          <a:bodyPr wrap="square">
-            <a:spAutoFit/>
-          </a:bodyPr>
-          <a:lstStyle/>
-          <a:p>
-            <a:pPr algn="l"/>
-            <a:r>
-              <a:rPr sz="1400" b="1" i="0">
-                <a:solidFill>
-                  <a:srgbClr val="FFFFFF"/>
-                </a:solidFill>
-              </a:rPr>
-              <a:t>🔍  大項目フィルター表示</a:t>
-            </a:r>
-          </a:p>
-        </p:txBody>
-      </p:sp>
-      <p:sp>
-        <p:nvSpPr>
-          <p:cNvPr id="25" name="Rectangle 24"/>
-          <p:cNvSpPr/>
-          <p:nvPr/>
-        </p:nvSpPr>
-        <p:spPr>
-          <a:xfrm>
-            <a:off x="6309360" y="2240280"/>
-            <a:ext cx="5486400" cy="365760"/>
-          </a:xfrm>
-          <a:prstGeom prst="rect">
-            <a:avLst/>
-          </a:prstGeom>
-          <a:solidFill>
-            <a:srgbClr val="8E44AD"/>
-          </a:solidFill>
-          <a:ln>
-            <a:noFill/>
-          </a:ln>
-        </p:spPr>
-        <p:style>
-          <a:lnRef idx="1">
-            <a:schemeClr val="accent1"/>
-          </a:lnRef>
-          <a:fillRef idx="3">
-            <a:schemeClr val="accent1"/>
-          </a:fillRef>
-          <a:effectRef idx="2">
-            <a:schemeClr val="accent1"/>
-          </a:effectRef>
-          <a:fontRef idx="minor">
-            <a:schemeClr val="lt1"/>
-          </a:fontRef>
-        </p:style>
-        <p:txBody>
-          <a:bodyPr rtlCol="0" anchor="ctr"/>
-          <a:lstStyle/>
-          <a:p>
-            <a:pPr algn="ctr"/>
-          </a:p>
-        </p:txBody>
-      </p:sp>
-      <p:sp>
-        <p:nvSpPr>
-          <p:cNvPr id="26" name="TextBox 25"/>
-          <p:cNvSpPr txBox="1"/>
-          <p:nvPr/>
-        </p:nvSpPr>
-        <p:spPr>
-          <a:xfrm>
-            <a:off x="6400800" y="2276856"/>
-            <a:ext cx="5303520" cy="320040"/>
-          </a:xfrm>
-          <a:prstGeom prst="rect">
-            <a:avLst/>
-          </a:prstGeom>
-          <a:noFill/>
-        </p:spPr>
-        <p:txBody>
-          <a:bodyPr wrap="square">
-            <a:spAutoFit/>
-          </a:bodyPr>
-          <a:lstStyle/>
-          <a:p>
-            <a:pPr algn="l"/>
-            <a:r>
-              <a:rPr sz="1300" b="1" i="0">
-                <a:solidFill>
-                  <a:srgbClr val="FFFFFF"/>
-                </a:solidFill>
-              </a:rPr>
-              <a:t>操作手順</a:t>
-            </a:r>
-          </a:p>
-        </p:txBody>
-      </p:sp>
-      <p:sp>
-        <p:nvSpPr>
-          <p:cNvPr id="27" name="Rectangle 26"/>
-          <p:cNvSpPr/>
-          <p:nvPr/>
-        </p:nvSpPr>
-        <p:spPr>
-          <a:xfrm>
-            <a:off x="6309360" y="2606040"/>
-            <a:ext cx="5486400" cy="1737360"/>
-          </a:xfrm>
-          <a:prstGeom prst="rect">
-            <a:avLst/>
-          </a:prstGeom>
-          <a:solidFill>
-            <a:srgbClr val="F5F6FA"/>
-          </a:solidFill>
-          <a:ln>
-            <a:noFill/>
-          </a:ln>
-        </p:spPr>
-        <p:style>
-          <a:lnRef idx="1">
-            <a:schemeClr val="accent1"/>
-          </a:lnRef>
-          <a:fillRef idx="3">
-            <a:schemeClr val="accent1"/>
-          </a:fillRef>
-          <a:effectRef idx="2">
-            <a:schemeClr val="accent1"/>
-          </a:effectRef>
-          <a:fontRef idx="minor">
-            <a:schemeClr val="lt1"/>
-          </a:fontRef>
-        </p:style>
-        <p:txBody>
-          <a:bodyPr rtlCol="0" anchor="ctr"/>
-          <a:lstStyle/>
-          <a:p>
-            <a:pPr algn="ctr"/>
-          </a:p>
-        </p:txBody>
-      </p:sp>
-      <p:sp>
-        <p:nvSpPr>
-          <p:cNvPr id="28" name="TextBox 27"/>
-          <p:cNvSpPr txBox="1"/>
-          <p:nvPr/>
-        </p:nvSpPr>
-        <p:spPr>
-          <a:xfrm>
-            <a:off x="6419088" y="2651760"/>
-            <a:ext cx="5266944" cy="1600199"/>
-          </a:xfrm>
-          <a:prstGeom prst="rect">
-            <a:avLst/>
-          </a:prstGeom>
-          <a:noFill/>
-        </p:spPr>
-        <p:txBody>
-          <a:bodyPr wrap="square">
-            <a:spAutoFit/>
-          </a:bodyPr>
-          <a:lstStyle/>
-          <a:p>
-            <a:pPr>
-              <a:spcBef>
-                <a:spcPts val="400"/>
-              </a:spcBef>
-            </a:pPr>
-            <a:r>
-              <a:rPr sz="1200">
-                <a:solidFill>
-                  <a:srgbClr val="2C3E50"/>
-                </a:solidFill>
-              </a:rPr>
-              <a:t>① Top 画面左サイドバー「大項目フィルター」を展開</a:t>
-            </a:r>
-          </a:p>
-          <a:p>
-            <a:pPr>
-              <a:spcBef>
-                <a:spcPts val="400"/>
-              </a:spcBef>
-            </a:pPr>
-            <a:r>
-              <a:rPr sz="1200">
-                <a:solidFill>
-                  <a:srgbClr val="2C3E50"/>
-                </a:solidFill>
-              </a:rPr>
-              <a:t>② 表示したい大項目をチェック（複数可）</a:t>
-            </a:r>
-          </a:p>
-          <a:p>
-            <a:pPr>
-              <a:spcBef>
-                <a:spcPts val="400"/>
-              </a:spcBef>
-            </a:pPr>
-            <a:r>
-              <a:rPr sz="1200">
-                <a:solidFill>
-                  <a:srgbClr val="2C3E50"/>
-                </a:solidFill>
-              </a:rPr>
-              <a:t>③ 対象プロジェクトをチェック</a:t>
-            </a:r>
-          </a:p>
-          <a:p>
-            <a:pPr>
-              <a:spcBef>
-                <a:spcPts val="400"/>
-              </a:spcBef>
-            </a:pPr>
-            <a:r>
-              <a:rPr sz="1200">
-                <a:solidFill>
-                  <a:srgbClr val="2C3E50"/>
-                </a:solidFill>
-              </a:rPr>
-              <a:t>④「フィルター表示」ボタンをクリック</a:t>
-            </a:r>
-          </a:p>
-          <a:p>
-            <a:pPr>
-              <a:spcBef>
-                <a:spcPts val="400"/>
-              </a:spcBef>
-            </a:pPr>
-            <a:r>
-              <a:rPr sz="1200">
-                <a:solidFill>
-                  <a:srgbClr val="2C3E50"/>
-                </a:solidFill>
-              </a:rPr>
-              <a:t>⑤ 選択した大項目のタスクのみが表示される</a:t>
-            </a:r>
-          </a:p>
-        </p:txBody>
-      </p:sp>
-      <p:sp>
-        <p:nvSpPr>
-          <p:cNvPr id="29" name="Rectangle 28"/>
-          <p:cNvSpPr/>
-          <p:nvPr/>
-        </p:nvSpPr>
-        <p:spPr>
-          <a:xfrm>
-            <a:off x="6309360" y="4434840"/>
-            <a:ext cx="5486400" cy="365760"/>
-          </a:xfrm>
-          <a:prstGeom prst="rect">
-            <a:avLst/>
-          </a:prstGeom>
-          <a:solidFill>
-            <a:srgbClr val="7F8C8D"/>
-          </a:solidFill>
-          <a:ln>
-            <a:noFill/>
-          </a:ln>
-        </p:spPr>
-        <p:style>
-          <a:lnRef idx="1">
-            <a:schemeClr val="accent1"/>
-          </a:lnRef>
-          <a:fillRef idx="3">
-            <a:schemeClr val="accent1"/>
-          </a:fillRef>
-          <a:effectRef idx="2">
-            <a:schemeClr val="accent1"/>
-          </a:effectRef>
-          <a:fontRef idx="minor">
-            <a:schemeClr val="lt1"/>
-          </a:fontRef>
-        </p:style>
-        <p:txBody>
-          <a:bodyPr rtlCol="0" anchor="ctr"/>
-          <a:lstStyle/>
-          <a:p>
-            <a:pPr algn="ctr"/>
-          </a:p>
-        </p:txBody>
-      </p:sp>
-      <p:sp>
-        <p:nvSpPr>
-          <p:cNvPr id="30" name="TextBox 29"/>
-          <p:cNvSpPr txBox="1"/>
-          <p:nvPr/>
-        </p:nvSpPr>
-        <p:spPr>
-          <a:xfrm>
-            <a:off x="6400800" y="4471416"/>
-            <a:ext cx="5303520" cy="320040"/>
-          </a:xfrm>
-          <a:prstGeom prst="rect">
-            <a:avLst/>
-          </a:prstGeom>
-          <a:noFill/>
-        </p:spPr>
-        <p:txBody>
-          <a:bodyPr wrap="square">
-            <a:spAutoFit/>
-          </a:bodyPr>
-          <a:lstStyle/>
-          <a:p>
-            <a:pPr algn="l"/>
-            <a:r>
-              <a:rPr sz="1300" b="1" i="0">
-                <a:solidFill>
-                  <a:srgbClr val="FFFFFF"/>
-                </a:solidFill>
-              </a:rPr>
-              <a:t>URL 形式</a:t>
-            </a:r>
-          </a:p>
-        </p:txBody>
-      </p:sp>
-      <p:sp>
-        <p:nvSpPr>
-          <p:cNvPr id="31" name="Rectangle 30"/>
-          <p:cNvSpPr/>
-          <p:nvPr/>
-        </p:nvSpPr>
-        <p:spPr>
-          <a:xfrm>
-            <a:off x="6309360" y="4800600"/>
-            <a:ext cx="5486400" cy="548640"/>
-          </a:xfrm>
-          <a:prstGeom prst="rect">
-            <a:avLst/>
-          </a:prstGeom>
-          <a:solidFill>
-            <a:srgbClr val="F5F6FA"/>
-          </a:solidFill>
-          <a:ln>
-            <a:noFill/>
-          </a:ln>
-        </p:spPr>
-        <p:style>
-          <a:lnRef idx="1">
-            <a:schemeClr val="accent1"/>
-          </a:lnRef>
-          <a:fillRef idx="3">
-            <a:schemeClr val="accent1"/>
-          </a:fillRef>
-          <a:effectRef idx="2">
-            <a:schemeClr val="accent1"/>
-          </a:effectRef>
-          <a:fontRef idx="minor">
-            <a:schemeClr val="lt1"/>
-          </a:fontRef>
-        </p:style>
-        <p:txBody>
-          <a:bodyPr rtlCol="0" anchor="ctr"/>
-          <a:lstStyle/>
-          <a:p>
-            <a:pPr algn="ctr"/>
-          </a:p>
-        </p:txBody>
-      </p:sp>
-      <p:sp>
-        <p:nvSpPr>
-          <p:cNvPr id="32" name="TextBox 31"/>
-          <p:cNvSpPr txBox="1"/>
-          <p:nvPr/>
-        </p:nvSpPr>
-        <p:spPr>
-          <a:xfrm>
-            <a:off x="6419088" y="4846320"/>
-            <a:ext cx="5266944" cy="411479"/>
-          </a:xfrm>
-          <a:prstGeom prst="rect">
-            <a:avLst/>
-          </a:prstGeom>
-          <a:noFill/>
-        </p:spPr>
-        <p:txBody>
-          <a:bodyPr wrap="square">
-            <a:spAutoFit/>
-          </a:bodyPr>
-          <a:lstStyle/>
-          <a:p>
-            <a:pPr>
-              <a:spcBef>
-                <a:spcPts val="400"/>
-              </a:spcBef>
-            </a:pPr>
-            <a:r>
-              <a:rPr sz="1200">
-                <a:solidFill>
-                  <a:srgbClr val="2C3E50"/>
-                </a:solidFill>
-              </a:rPr>
-              <a:t>/schedule?projects=1&amp;projects=2</a:t>
-            </a:r>
-          </a:p>
-          <a:p>
-            <a:pPr>
-              <a:spcBef>
-                <a:spcPts val="400"/>
-              </a:spcBef>
-            </a:pPr>
-            <a:r>
-              <a:rPr sz="1200">
-                <a:solidFill>
-                  <a:srgbClr val="2C3E50"/>
-                </a:solidFill>
-              </a:rPr>
               <a:t>           &amp;catfilter=Phase1要件定義</a:t>
             </a:r>
           </a:p>
@@ -5183,7 +5138,7 @@
       </p:sp>
       <p:sp>
         <p:nvSpPr>
-          <p:cNvPr id="33" name="Rectangle 32"/>
+          <p:cNvPr id="32" name="Rectangle 31"/>
           <p:cNvSpPr/>
           <p:nvPr/>
         </p:nvSpPr>
@@ -5226,7 +5181,7 @@
       </p:sp>
       <p:sp>
         <p:nvSpPr>
-          <p:cNvPr id="34" name="TextBox 33"/>
+          <p:cNvPr id="33" name="TextBox 32"/>
           <p:cNvSpPr txBox="1"/>
           <p:nvPr/>
         </p:nvSpPr>
@@ -5260,7 +5215,7 @@
       </p:sp>
       <p:sp>
         <p:nvSpPr>
-          <p:cNvPr id="35" name="TextBox 34"/>
+          <p:cNvPr id="34" name="TextBox 33"/>
           <p:cNvSpPr txBox="1"/>
           <p:nvPr/>
         </p:nvSpPr>
@@ -13861,7 +13816,7 @@
         <p:spPr>
           <a:xfrm>
             <a:off x="2697480" y="2724912"/>
-            <a:ext cx="1097280" cy="292608"/>
+            <a:ext cx="1463040" cy="292608"/>
           </a:xfrm>
           <a:prstGeom prst="rect">
             <a:avLst/>
@@ -13895,7 +13850,7 @@
         <p:spPr>
           <a:xfrm>
             <a:off x="2926080" y="2724912"/>
-            <a:ext cx="1097280" cy="292608"/>
+            <a:ext cx="1463040" cy="292608"/>
           </a:xfrm>
           <a:prstGeom prst="rect">
             <a:avLst/>
@@ -13915,7 +13870,7 @@
                   <a:srgbClr val="4A90D9"/>
                 </a:solidFill>
               </a:rPr>
-              <a:t>プロジェクト名</a:t>
+              <a:t>モデル名 / プロジェクト名</a:t>
             </a:r>
           </a:p>
         </p:txBody>
@@ -13928,8 +13883,8 @@
         </p:nvSpPr>
         <p:spPr>
           <a:xfrm>
-            <a:off x="4754880" y="2724912"/>
-            <a:ext cx="1097280" cy="292608"/>
+            <a:off x="5120640" y="2724912"/>
+            <a:ext cx="1463040" cy="292608"/>
           </a:xfrm>
           <a:prstGeom prst="rect">
             <a:avLst/>
@@ -13962,8 +13917,8 @@
         </p:nvSpPr>
         <p:spPr>
           <a:xfrm>
-            <a:off x="5852160" y="2724912"/>
-            <a:ext cx="1097280" cy="292608"/>
+            <a:off x="6126480" y="2724912"/>
+            <a:ext cx="1463040" cy="292608"/>
           </a:xfrm>
           <a:prstGeom prst="rect">
             <a:avLst/>
@@ -13996,8 +13951,8 @@
         </p:nvSpPr>
         <p:spPr>
           <a:xfrm>
-            <a:off x="6492240" y="2724912"/>
-            <a:ext cx="1097280" cy="292608"/>
+            <a:off x="6720840" y="2724912"/>
+            <a:ext cx="1463040" cy="292608"/>
           </a:xfrm>
           <a:prstGeom prst="rect">
             <a:avLst/>
@@ -14030,8 +13985,8 @@
         </p:nvSpPr>
         <p:spPr>
           <a:xfrm>
-            <a:off x="7863840" y="2724912"/>
-            <a:ext cx="1097280" cy="292608"/>
+            <a:off x="8046720" y="2724912"/>
+            <a:ext cx="1463040" cy="292608"/>
           </a:xfrm>
           <a:prstGeom prst="rect">
             <a:avLst/>
@@ -14142,7 +14097,7 @@
         <p:spPr>
           <a:xfrm>
             <a:off x="2926080" y="3182112"/>
-            <a:ext cx="1828800" cy="274320"/>
+            <a:ext cx="1005840" cy="274320"/>
           </a:xfrm>
           <a:prstGeom prst="rect">
             <a:avLst/>
@@ -14157,6 +14112,40 @@
           <a:p>
             <a:pPr algn="l"/>
             <a:r>
+              <a:rPr sz="900" b="1" i="0">
+                <a:solidFill>
+                  <a:srgbClr val="7F8C8D"/>
+                </a:solidFill>
+              </a:rPr>
+              <a:t>ModelA /</a:t>
+            </a:r>
+          </a:p>
+        </p:txBody>
+      </p:sp>
+      <p:sp>
+        <p:nvSpPr>
+          <p:cNvPr id="26" name="TextBox 25"/>
+          <p:cNvSpPr txBox="1"/>
+          <p:nvPr/>
+        </p:nvSpPr>
+        <p:spPr>
+          <a:xfrm>
+            <a:off x="3657600" y="3182112"/>
+            <a:ext cx="1371600" cy="274320"/>
+          </a:xfrm>
+          <a:prstGeom prst="rect">
+            <a:avLst/>
+          </a:prstGeom>
+          <a:noFill/>
+        </p:spPr>
+        <p:txBody>
+          <a:bodyPr wrap="square">
+            <a:spAutoFit/>
+          </a:bodyPr>
+          <a:lstStyle/>
+          <a:p>
+            <a:pPr algn="l"/>
+            <a:r>
               <a:rPr sz="1100" b="0" i="0">
                 <a:solidFill>
                   <a:srgbClr val="4A90D9"/>
@@ -14169,14 +14158,14 @@
       </p:sp>
       <p:sp>
         <p:nvSpPr>
-          <p:cNvPr id="26" name="TextBox 25"/>
-          <p:cNvSpPr txBox="1"/>
-          <p:nvPr/>
-        </p:nvSpPr>
-        <p:spPr>
-          <a:xfrm>
-            <a:off x="4754880" y="3182112"/>
-            <a:ext cx="1005840" cy="274320"/>
+          <p:cNvPr id="27" name="TextBox 26"/>
+          <p:cNvSpPr txBox="1"/>
+          <p:nvPr/>
+        </p:nvSpPr>
+        <p:spPr>
+          <a:xfrm>
+            <a:off x="5120640" y="3182112"/>
+            <a:ext cx="914400" cy="274320"/>
           </a:xfrm>
           <a:prstGeom prst="rect">
             <a:avLst/>
@@ -14203,14 +14192,14 @@
       </p:sp>
       <p:sp>
         <p:nvSpPr>
-          <p:cNvPr id="27" name="TextBox 26"/>
-          <p:cNvSpPr txBox="1"/>
-          <p:nvPr/>
-        </p:nvSpPr>
-        <p:spPr>
-          <a:xfrm>
-            <a:off x="5852160" y="3182112"/>
-            <a:ext cx="594360" cy="274320"/>
+          <p:cNvPr id="28" name="TextBox 27"/>
+          <p:cNvSpPr txBox="1"/>
+          <p:nvPr/>
+        </p:nvSpPr>
+        <p:spPr>
+          <a:xfrm>
+            <a:off x="6126480" y="3182112"/>
+            <a:ext cx="548640" cy="274320"/>
           </a:xfrm>
           <a:prstGeom prst="rect">
             <a:avLst/>
@@ -14237,13 +14226,13 @@
       </p:sp>
       <p:sp>
         <p:nvSpPr>
-          <p:cNvPr id="28" name="TextBox 27"/>
-          <p:cNvSpPr txBox="1"/>
-          <p:nvPr/>
-        </p:nvSpPr>
-        <p:spPr>
-          <a:xfrm>
-            <a:off x="6492240" y="3182112"/>
+          <p:cNvPr id="29" name="TextBox 28"/>
+          <p:cNvSpPr txBox="1"/>
+          <p:nvPr/>
+        </p:nvSpPr>
+        <p:spPr>
+          <a:xfrm>
+            <a:off x="6720840" y="3182112"/>
             <a:ext cx="1097280" cy="274320"/>
           </a:xfrm>
           <a:prstGeom prst="rect">
@@ -14271,14 +14260,14 @@
       </p:sp>
       <p:sp>
         <p:nvSpPr>
-          <p:cNvPr id="29" name="TextBox 28"/>
-          <p:cNvSpPr txBox="1"/>
-          <p:nvPr/>
-        </p:nvSpPr>
-        <p:spPr>
-          <a:xfrm>
-            <a:off x="7863840" y="3182112"/>
-            <a:ext cx="685800" cy="274320"/>
+          <p:cNvPr id="30" name="TextBox 29"/>
+          <p:cNvSpPr txBox="1"/>
+          <p:nvPr/>
+        </p:nvSpPr>
+        <p:spPr>
+          <a:xfrm>
+            <a:off x="8046720" y="3182112"/>
+            <a:ext cx="640080" cy="274320"/>
           </a:xfrm>
           <a:prstGeom prst="rect">
             <a:avLst/>
@@ -14305,7 +14294,7 @@
       </p:sp>
       <p:sp>
         <p:nvSpPr>
-          <p:cNvPr id="30" name="Rectangle 29"/>
+          <p:cNvPr id="31" name="Rectangle 30"/>
           <p:cNvSpPr/>
           <p:nvPr/>
         </p:nvSpPr>
@@ -14348,7 +14337,7 @@
       </p:sp>
       <p:sp>
         <p:nvSpPr>
-          <p:cNvPr id="31" name="TextBox 30"/>
+          <p:cNvPr id="32" name="TextBox 31"/>
           <p:cNvSpPr txBox="1"/>
           <p:nvPr/>
         </p:nvSpPr>
@@ -14382,14 +14371,14 @@
       </p:sp>
       <p:sp>
         <p:nvSpPr>
-          <p:cNvPr id="32" name="TextBox 31"/>
+          <p:cNvPr id="33" name="TextBox 32"/>
           <p:cNvSpPr txBox="1"/>
           <p:nvPr/>
         </p:nvSpPr>
         <p:spPr>
           <a:xfrm>
             <a:off x="2926080" y="3639312"/>
-            <a:ext cx="1828800" cy="274320"/>
+            <a:ext cx="2103120" cy="274320"/>
           </a:xfrm>
           <a:prstGeom prst="rect">
             <a:avLst/>
@@ -14416,14 +14405,14 @@
       </p:sp>
       <p:sp>
         <p:nvSpPr>
-          <p:cNvPr id="33" name="TextBox 32"/>
-          <p:cNvSpPr txBox="1"/>
-          <p:nvPr/>
-        </p:nvSpPr>
-        <p:spPr>
-          <a:xfrm>
-            <a:off x="4754880" y="3639312"/>
-            <a:ext cx="1005840" cy="274320"/>
+          <p:cNvPr id="34" name="TextBox 33"/>
+          <p:cNvSpPr txBox="1"/>
+          <p:nvPr/>
+        </p:nvSpPr>
+        <p:spPr>
+          <a:xfrm>
+            <a:off x="5120640" y="3639312"/>
+            <a:ext cx="914400" cy="274320"/>
           </a:xfrm>
           <a:prstGeom prst="rect">
             <a:avLst/>
@@ -14450,14 +14439,14 @@
       </p:sp>
       <p:sp>
         <p:nvSpPr>
-          <p:cNvPr id="34" name="TextBox 33"/>
-          <p:cNvSpPr txBox="1"/>
-          <p:nvPr/>
-        </p:nvSpPr>
-        <p:spPr>
-          <a:xfrm>
-            <a:off x="5852160" y="3639312"/>
-            <a:ext cx="594360" cy="274320"/>
+          <p:cNvPr id="35" name="TextBox 34"/>
+          <p:cNvSpPr txBox="1"/>
+          <p:nvPr/>
+        </p:nvSpPr>
+        <p:spPr>
+          <a:xfrm>
+            <a:off x="6126480" y="3639312"/>
+            <a:ext cx="548640" cy="274320"/>
           </a:xfrm>
           <a:prstGeom prst="rect">
             <a:avLst/>
@@ -14484,13 +14473,13 @@
       </p:sp>
       <p:sp>
         <p:nvSpPr>
-          <p:cNvPr id="35" name="TextBox 34"/>
-          <p:cNvSpPr txBox="1"/>
-          <p:nvPr/>
-        </p:nvSpPr>
-        <p:spPr>
-          <a:xfrm>
-            <a:off x="6492240" y="3639312"/>
+          <p:cNvPr id="36" name="TextBox 35"/>
+          <p:cNvSpPr txBox="1"/>
+          <p:nvPr/>
+        </p:nvSpPr>
+        <p:spPr>
+          <a:xfrm>
+            <a:off x="6720840" y="3639312"/>
             <a:ext cx="1097280" cy="274320"/>
           </a:xfrm>
           <a:prstGeom prst="rect">
@@ -14518,14 +14507,14 @@
       </p:sp>
       <p:sp>
         <p:nvSpPr>
-          <p:cNvPr id="36" name="TextBox 35"/>
-          <p:cNvSpPr txBox="1"/>
-          <p:nvPr/>
-        </p:nvSpPr>
-        <p:spPr>
-          <a:xfrm>
-            <a:off x="7863840" y="3639312"/>
-            <a:ext cx="685800" cy="274320"/>
+          <p:cNvPr id="37" name="TextBox 36"/>
+          <p:cNvSpPr txBox="1"/>
+          <p:nvPr/>
+        </p:nvSpPr>
+        <p:spPr>
+          <a:xfrm>
+            <a:off x="8046720" y="3639312"/>
+            <a:ext cx="640080" cy="274320"/>
           </a:xfrm>
           <a:prstGeom prst="rect">
             <a:avLst/>
@@ -14552,7 +14541,7 @@
       </p:sp>
       <p:sp>
         <p:nvSpPr>
-          <p:cNvPr id="37" name="Rectangle 36"/>
+          <p:cNvPr id="38" name="Rectangle 37"/>
           <p:cNvSpPr/>
           <p:nvPr/>
         </p:nvSpPr>
@@ -14595,7 +14584,7 @@
       </p:sp>
       <p:sp>
         <p:nvSpPr>
-          <p:cNvPr id="38" name="TextBox 37"/>
+          <p:cNvPr id="39" name="TextBox 38"/>
           <p:cNvSpPr txBox="1"/>
           <p:nvPr/>
         </p:nvSpPr>
@@ -14629,14 +14618,14 @@
       </p:sp>
       <p:sp>
         <p:nvSpPr>
-          <p:cNvPr id="39" name="TextBox 38"/>
+          <p:cNvPr id="40" name="TextBox 39"/>
           <p:cNvSpPr txBox="1"/>
           <p:nvPr/>
         </p:nvSpPr>
         <p:spPr>
           <a:xfrm>
             <a:off x="2926080" y="4096511"/>
-            <a:ext cx="1828800" cy="274320"/>
+            <a:ext cx="1005840" cy="274320"/>
           </a:xfrm>
           <a:prstGeom prst="rect">
             <a:avLst/>
@@ -14651,6 +14640,40 @@
           <a:p>
             <a:pPr algn="l"/>
             <a:r>
+              <a:rPr sz="900" b="1" i="0">
+                <a:solidFill>
+                  <a:srgbClr val="7F8C8D"/>
+                </a:solidFill>
+              </a:rPr>
+              <a:t>ModelB /</a:t>
+            </a:r>
+          </a:p>
+        </p:txBody>
+      </p:sp>
+      <p:sp>
+        <p:nvSpPr>
+          <p:cNvPr id="41" name="TextBox 40"/>
+          <p:cNvSpPr txBox="1"/>
+          <p:nvPr/>
+        </p:nvSpPr>
+        <p:spPr>
+          <a:xfrm>
+            <a:off x="3657600" y="4096511"/>
+            <a:ext cx="1371600" cy="274320"/>
+          </a:xfrm>
+          <a:prstGeom prst="rect">
+            <a:avLst/>
+          </a:prstGeom>
+          <a:noFill/>
+        </p:spPr>
+        <p:txBody>
+          <a:bodyPr wrap="square">
+            <a:spAutoFit/>
+          </a:bodyPr>
+          <a:lstStyle/>
+          <a:p>
+            <a:pPr algn="l"/>
+            <a:r>
               <a:rPr sz="1100" b="0" i="0">
                 <a:solidFill>
                   <a:srgbClr val="4A90D9"/>
@@ -14663,14 +14686,14 @@
       </p:sp>
       <p:sp>
         <p:nvSpPr>
-          <p:cNvPr id="40" name="TextBox 39"/>
-          <p:cNvSpPr txBox="1"/>
-          <p:nvPr/>
-        </p:nvSpPr>
-        <p:spPr>
-          <a:xfrm>
-            <a:off x="4754880" y="4096511"/>
-            <a:ext cx="1005840" cy="274320"/>
+          <p:cNvPr id="42" name="TextBox 41"/>
+          <p:cNvSpPr txBox="1"/>
+          <p:nvPr/>
+        </p:nvSpPr>
+        <p:spPr>
+          <a:xfrm>
+            <a:off x="5120640" y="4096511"/>
+            <a:ext cx="914400" cy="274320"/>
           </a:xfrm>
           <a:prstGeom prst="rect">
             <a:avLst/>
@@ -14697,14 +14720,14 @@
       </p:sp>
       <p:sp>
         <p:nvSpPr>
-          <p:cNvPr id="41" name="TextBox 40"/>
-          <p:cNvSpPr txBox="1"/>
-          <p:nvPr/>
-        </p:nvSpPr>
-        <p:spPr>
-          <a:xfrm>
-            <a:off x="5852160" y="4096511"/>
-            <a:ext cx="594360" cy="274320"/>
+          <p:cNvPr id="43" name="TextBox 42"/>
+          <p:cNvSpPr txBox="1"/>
+          <p:nvPr/>
+        </p:nvSpPr>
+        <p:spPr>
+          <a:xfrm>
+            <a:off x="6126480" y="4096511"/>
+            <a:ext cx="548640" cy="274320"/>
           </a:xfrm>
           <a:prstGeom prst="rect">
             <a:avLst/>
@@ -14731,13 +14754,13 @@
       </p:sp>
       <p:sp>
         <p:nvSpPr>
-          <p:cNvPr id="42" name="TextBox 41"/>
-          <p:cNvSpPr txBox="1"/>
-          <p:nvPr/>
-        </p:nvSpPr>
-        <p:spPr>
-          <a:xfrm>
-            <a:off x="6492240" y="4096511"/>
+          <p:cNvPr id="44" name="TextBox 43"/>
+          <p:cNvSpPr txBox="1"/>
+          <p:nvPr/>
+        </p:nvSpPr>
+        <p:spPr>
+          <a:xfrm>
+            <a:off x="6720840" y="4096511"/>
             <a:ext cx="1097280" cy="274320"/>
           </a:xfrm>
           <a:prstGeom prst="rect">
@@ -14765,14 +14788,14 @@
       </p:sp>
       <p:sp>
         <p:nvSpPr>
-          <p:cNvPr id="43" name="TextBox 42"/>
-          <p:cNvSpPr txBox="1"/>
-          <p:nvPr/>
-        </p:nvSpPr>
-        <p:spPr>
-          <a:xfrm>
-            <a:off x="7863840" y="4096511"/>
-            <a:ext cx="685800" cy="274320"/>
+          <p:cNvPr id="45" name="TextBox 44"/>
+          <p:cNvSpPr txBox="1"/>
+          <p:nvPr/>
+        </p:nvSpPr>
+        <p:spPr>
+          <a:xfrm>
+            <a:off x="8046720" y="4096511"/>
+            <a:ext cx="640080" cy="274320"/>
           </a:xfrm>
           <a:prstGeom prst="rect">
             <a:avLst/>
@@ -14799,7 +14822,7 @@
       </p:sp>
       <p:sp>
         <p:nvSpPr>
-          <p:cNvPr id="44" name="Rectangle 43"/>
+          <p:cNvPr id="46" name="Rectangle 45"/>
           <p:cNvSpPr/>
           <p:nvPr/>
         </p:nvSpPr>
@@ -14842,7 +14865,7 @@
       </p:sp>
       <p:sp>
         <p:nvSpPr>
-          <p:cNvPr id="45" name="TextBox 44"/>
+          <p:cNvPr id="47" name="TextBox 46"/>
           <p:cNvSpPr txBox="1"/>
           <p:nvPr/>
         </p:nvSpPr>
@@ -14876,7 +14899,7 @@
       </p:sp>
       <p:sp>
         <p:nvSpPr>
-          <p:cNvPr id="46" name="TextBox 45"/>
+          <p:cNvPr id="48" name="TextBox 47"/>
           <p:cNvSpPr txBox="1"/>
           <p:nvPr/>
         </p:nvSpPr>
@@ -15541,7 +15564,7 @@
                   <a:srgbClr val="2C3E50"/>
                 </a:solidFill>
               </a:rPr>
-              <a:t>プロジェクト名を入力（必須）</a:t>
+              <a:t>モデル名を入力（任意・最上位分類）</a:t>
             </a:r>
           </a:p>
         </p:txBody>
@@ -15695,7 +15718,7 @@
                   <a:srgbClr val="2C3E50"/>
                 </a:solidFill>
               </a:rPr>
-              <a:t>表示色・客先名・ベースPJ を任意入力</a:t>
+              <a:t>プロジェクト名を入力（必須）</a:t>
             </a:r>
           </a:p>
         </p:txBody>
@@ -15849,7 +15872,7 @@
                   <a:srgbClr val="2C3E50"/>
                 </a:solidFill>
               </a:rPr>
-              <a:t>業務ステータスを選択（未開始 / 作業中 / 中断 / 終了）</a:t>
+              <a:t>表示色・客先名・ベースPJ を任意入力</a:t>
             </a:r>
           </a:p>
         </p:txBody>
@@ -16003,7 +16026,7 @@
                   <a:srgbClr val="2C3E50"/>
                 </a:solidFill>
               </a:rPr>
-              <a:t>「作成」ボタンをクリックして保存</a:t>
+              <a:t>業務ステータスを選択（未開始 / 作業中 / 中断 / 終了）</a:t>
             </a:r>
           </a:p>
         </p:txBody>
@@ -16157,7 +16180,7 @@
                   <a:srgbClr val="2C3E50"/>
                 </a:solidFill>
               </a:rPr>
-              <a:t>プロジェクト名をクリックして Schedule 画面へ移動</a:t>
+              <a:t>「作成」ボタンをクリックして保存</a:t>
             </a:r>
           </a:p>
         </p:txBody>
@@ -16248,7 +16271,7 @@
         <p:spPr>
           <a:xfrm>
             <a:off x="5943600" y="2103120"/>
-            <a:ext cx="5943600" cy="2468880"/>
+            <a:ext cx="5943600" cy="3063240"/>
           </a:xfrm>
           <a:prstGeom prst="rect">
             <a:avLst/>
@@ -16291,7 +16314,7 @@
         <p:spPr>
           <a:xfrm>
             <a:off x="6053328" y="2148840"/>
-            <a:ext cx="5724144" cy="2331720"/>
+            <a:ext cx="5724144" cy="2926080"/>
           </a:xfrm>
           <a:prstGeom prst="rect">
             <a:avLst/>
@@ -16315,7 +16338,7 @@
                   <a:srgbClr val="2C3E50"/>
                 </a:solidFill>
               </a:rPr>
-              <a:t>プロジェクト名 ★ 必須</a:t>
+              <a:t>モデル名       任意テキスト（最上位分類）</a:t>
             </a:r>
           </a:p>
           <a:p>
@@ -16330,7 +16353,7 @@
                   <a:srgbClr val="2C3E50"/>
                 </a:solidFill>
               </a:rPr>
-              <a:t>説明           任意テキスト</a:t>
+              <a:t>プロジェクト名 ★ 必須</a:t>
             </a:r>
           </a:p>
           <a:p>
@@ -16345,7 +16368,7 @@
                   <a:srgbClr val="2C3E50"/>
                 </a:solidFill>
               </a:rPr>
-              <a:t>表示色         HEX カラー（#4A90D9 等）</a:t>
+              <a:t>説明           任意テキスト</a:t>
             </a:r>
           </a:p>
           <a:p>
@@ -16360,7 +16383,7 @@
                   <a:srgbClr val="2C3E50"/>
                 </a:solidFill>
               </a:rPr>
-              <a:t>業務ステータス 未開始 / 作業中 / 中断 / 終了</a:t>
+              <a:t>表示色         HEX カラー（#4A90D9 等）</a:t>
             </a:r>
           </a:p>
           <a:p>
@@ -16375,7 +16398,7 @@
                   <a:srgbClr val="2C3E50"/>
                 </a:solidFill>
               </a:rPr>
-              <a:t>客先名         顧客企業名</a:t>
+              <a:t>業務ステータス 未開始 / 作業中 / 中断 / 終了</a:t>
             </a:r>
           </a:p>
           <a:p>
@@ -16390,7 +16413,7 @@
                   <a:srgbClr val="2C3E50"/>
                 </a:solidFill>
               </a:rPr>
-              <a:t>ベースPJ       参照元プロジェクト名</a:t>
+              <a:t>客先名         顧客企業名</a:t>
             </a:r>
           </a:p>
           <a:p>
@@ -16405,6 +16428,36 @@
                   <a:srgbClr val="2C3E50"/>
                 </a:solidFill>
               </a:rPr>
+              <a:t>ベースPJ       参照元プロジェクト名</a:t>
+            </a:r>
+          </a:p>
+          <a:p>
+            <a:pPr>
+              <a:spcBef>
+                <a:spcPts val="400"/>
+              </a:spcBef>
+            </a:pPr>
+            <a:r>
+              <a:rPr sz="1200">
+                <a:solidFill>
+                  <a:srgbClr val="2C3E50"/>
+                </a:solidFill>
+              </a:rPr>
+              <a:t>サムネイル画像 PNG/JPEG（任意・ヘッダーに表示）</a:t>
+            </a:r>
+          </a:p>
+          <a:p>
+            <a:pPr>
+              <a:spcBef>
+                <a:spcPts val="400"/>
+              </a:spcBef>
+            </a:pPr>
+            <a:r>
+              <a:rPr sz="1200">
+                <a:solidFill>
+                  <a:srgbClr val="2C3E50"/>
+                </a:solidFill>
+              </a:rPr>
               <a:t>表示モード     Day/Week/Month/Quarter</a:t>
             </a:r>
           </a:p>
@@ -16418,8 +16471,8 @@
         </p:nvSpPr>
         <p:spPr>
           <a:xfrm>
-            <a:off x="5943600" y="4709160"/>
-            <a:ext cx="5943600" cy="1828800"/>
+            <a:off x="5943600" y="5303520"/>
+            <a:ext cx="5943600" cy="1234440"/>
           </a:xfrm>
           <a:prstGeom prst="rect">
             <a:avLst/>
@@ -16461,7 +16514,7 @@
         </p:nvSpPr>
         <p:spPr>
           <a:xfrm>
-            <a:off x="5943600" y="4709160"/>
+            <a:off x="5943600" y="5303520"/>
             <a:ext cx="5943600" cy="365760"/>
           </a:xfrm>
           <a:prstGeom prst="rect">
@@ -16504,7 +16557,7 @@
         </p:nvSpPr>
         <p:spPr>
           <a:xfrm>
-            <a:off x="6035040" y="4736592"/>
+            <a:off x="6035040" y="5330952"/>
             <a:ext cx="5760720" cy="320040"/>
           </a:xfrm>
           <a:prstGeom prst="rect">
@@ -16538,8 +16591,8 @@
         </p:nvSpPr>
         <p:spPr>
           <a:xfrm>
-            <a:off x="6035040" y="5120640"/>
-            <a:ext cx="5760720" cy="1325880"/>
+            <a:off x="6035040" y="5715000"/>
+            <a:ext cx="5760720" cy="749808"/>
           </a:xfrm>
           <a:prstGeom prst="rect">
             <a:avLst/>
@@ -16860,14 +16913,91 @@
       </p:sp>
       <p:sp>
         <p:nvSpPr>
-          <p:cNvPr id="9" name="TextBox 8"/>
-          <p:cNvSpPr txBox="1"/>
-          <p:nvPr/>
-        </p:nvSpPr>
-        <p:spPr>
-          <a:xfrm>
-            <a:off x="365760" y="1828800"/>
-            <a:ext cx="2560320" cy="384048"/>
+          <p:cNvPr id="9" name="Rectangle 8"/>
+          <p:cNvSpPr/>
+          <p:nvPr/>
+        </p:nvSpPr>
+        <p:spPr>
+          <a:xfrm>
+            <a:off x="822960" y="1792224"/>
+            <a:ext cx="502920" cy="347472"/>
+          </a:xfrm>
+          <a:prstGeom prst="rect">
+            <a:avLst/>
+          </a:prstGeom>
+          <a:solidFill>
+            <a:srgbClr val="5AA0E9"/>
+          </a:solidFill>
+          <a:ln>
+            <a:noFill/>
+          </a:ln>
+        </p:spPr>
+        <p:style>
+          <a:lnRef idx="1">
+            <a:schemeClr val="accent1"/>
+          </a:lnRef>
+          <a:fillRef idx="3">
+            <a:schemeClr val="accent1"/>
+          </a:fillRef>
+          <a:effectRef idx="2">
+            <a:schemeClr val="accent1"/>
+          </a:effectRef>
+          <a:fontRef idx="minor">
+            <a:schemeClr val="lt1"/>
+          </a:fontRef>
+        </p:style>
+        <p:txBody>
+          <a:bodyPr rtlCol="0" anchor="ctr"/>
+          <a:lstStyle/>
+          <a:p>
+            <a:pPr algn="ctr"/>
+          </a:p>
+        </p:txBody>
+      </p:sp>
+      <p:sp>
+        <p:nvSpPr>
+          <p:cNvPr id="10" name="TextBox 9"/>
+          <p:cNvSpPr txBox="1"/>
+          <p:nvPr/>
+        </p:nvSpPr>
+        <p:spPr>
+          <a:xfrm>
+            <a:off x="822960" y="1801368"/>
+            <a:ext cx="502920" cy="320040"/>
+          </a:xfrm>
+          <a:prstGeom prst="rect">
+            <a:avLst/>
+          </a:prstGeom>
+          <a:noFill/>
+        </p:spPr>
+        <p:txBody>
+          <a:bodyPr wrap="square">
+            <a:spAutoFit/>
+          </a:bodyPr>
+          <a:lstStyle/>
+          <a:p>
+            <a:pPr algn="ctr"/>
+            <a:r>
+              <a:rPr sz="1200" b="0" i="0">
+                <a:solidFill>
+                  <a:srgbClr val="FFFFFF"/>
+                </a:solidFill>
+              </a:rPr>
+              <a:t>🖼</a:t>
+            </a:r>
+          </a:p>
+        </p:txBody>
+      </p:sp>
+      <p:sp>
+        <p:nvSpPr>
+          <p:cNvPr id="11" name="TextBox 10"/>
+          <p:cNvSpPr txBox="1"/>
+          <p:nvPr/>
+        </p:nvSpPr>
+        <p:spPr>
+          <a:xfrm>
+            <a:off x="1371600" y="1828800"/>
+            <a:ext cx="914400" cy="347472"/>
           </a:xfrm>
           <a:prstGeom prst="rect">
             <a:avLst/>
@@ -16882,87 +17012,53 @@
           <a:p>
             <a:pPr algn="l"/>
             <a:r>
-              <a:rPr sz="1000" b="0" i="0">
+              <a:rPr sz="900" b="0" i="0">
+                <a:solidFill>
+                  <a:srgbClr val="CCDDFF"/>
+                </a:solidFill>
+              </a:rPr>
+              <a:t>ModelA  /</a:t>
+            </a:r>
+          </a:p>
+        </p:txBody>
+      </p:sp>
+      <p:sp>
+        <p:nvSpPr>
+          <p:cNvPr id="12" name="TextBox 11"/>
+          <p:cNvSpPr txBox="1"/>
+          <p:nvPr/>
+        </p:nvSpPr>
+        <p:spPr>
+          <a:xfrm>
+            <a:off x="2286000" y="1810512"/>
+            <a:ext cx="2011680" cy="384048"/>
+          </a:xfrm>
+          <a:prstGeom prst="rect">
+            <a:avLst/>
+          </a:prstGeom>
+          <a:noFill/>
+        </p:spPr>
+        <p:txBody>
+          <a:bodyPr wrap="square">
+            <a:spAutoFit/>
+          </a:bodyPr>
+          <a:lstStyle/>
+          <a:p>
+            <a:pPr algn="l"/>
+            <a:r>
+              <a:rPr sz="1100" b="1" i="0">
                 <a:solidFill>
                   <a:srgbClr val="FFFFFF"/>
                 </a:solidFill>
               </a:rPr>
-              <a:t>← Top</a:t>
-            </a:r>
-          </a:p>
-        </p:txBody>
-      </p:sp>
-      <p:sp>
-        <p:nvSpPr>
-          <p:cNvPr id="10" name="TextBox 9"/>
-          <p:cNvSpPr txBox="1"/>
-          <p:nvPr/>
-        </p:nvSpPr>
-        <p:spPr>
-          <a:xfrm>
-            <a:off x="1280160" y="1828800"/>
-            <a:ext cx="2560320" cy="384048"/>
-          </a:xfrm>
-          <a:prstGeom prst="rect">
-            <a:avLst/>
-          </a:prstGeom>
-          <a:noFill/>
-        </p:spPr>
-        <p:txBody>
-          <a:bodyPr wrap="square">
-            <a:spAutoFit/>
-          </a:bodyPr>
-          <a:lstStyle/>
-          <a:p>
-            <a:pPr algn="l"/>
-            <a:r>
-              <a:rPr sz="1000" b="0" i="0">
-                <a:solidFill>
-                  <a:srgbClr val="FFFFFF"/>
-                </a:solidFill>
-              </a:rPr>
-              <a:t>📅 opeSchedule</a:t>
-            </a:r>
-          </a:p>
-        </p:txBody>
-      </p:sp>
-      <p:sp>
-        <p:nvSpPr>
-          <p:cNvPr id="11" name="TextBox 10"/>
-          <p:cNvSpPr txBox="1"/>
-          <p:nvPr/>
-        </p:nvSpPr>
-        <p:spPr>
-          <a:xfrm>
-            <a:off x="3108960" y="1828800"/>
-            <a:ext cx="2560320" cy="384048"/>
-          </a:xfrm>
-          <a:prstGeom prst="rect">
-            <a:avLst/>
-          </a:prstGeom>
-          <a:noFill/>
-        </p:spPr>
-        <p:txBody>
-          <a:bodyPr wrap="square">
-            <a:spAutoFit/>
-          </a:bodyPr>
-          <a:lstStyle/>
-          <a:p>
-            <a:pPr algn="l"/>
-            <a:r>
-              <a:rPr sz="1000" b="0" i="0">
-                <a:solidFill>
-                  <a:srgbClr val="FFFFFF"/>
-                </a:solidFill>
-              </a:rPr>
-              <a:t>PJ名</a:t>
-            </a:r>
-          </a:p>
-        </p:txBody>
-      </p:sp>
-      <p:sp>
-        <p:nvSpPr>
-          <p:cNvPr id="12" name="TextBox 11"/>
+              <a:t>ECサイトリニューアル</a:t>
+            </a:r>
+          </a:p>
+        </p:txBody>
+      </p:sp>
+      <p:sp>
+        <p:nvSpPr>
+          <p:cNvPr id="13" name="TextBox 12"/>
           <p:cNvSpPr txBox="1"/>
           <p:nvPr/>
         </p:nvSpPr>
@@ -16996,7 +17092,7 @@
       </p:sp>
       <p:sp>
         <p:nvSpPr>
-          <p:cNvPr id="13" name="TextBox 12"/>
+          <p:cNvPr id="14" name="TextBox 13"/>
           <p:cNvSpPr txBox="1"/>
           <p:nvPr/>
         </p:nvSpPr>
@@ -17030,7 +17126,41 @@
       </p:sp>
       <p:sp>
         <p:nvSpPr>
-          <p:cNvPr id="14" name="Rectangle 13"/>
+          <p:cNvPr id="15" name="TextBox 14"/>
+          <p:cNvSpPr txBox="1"/>
+          <p:nvPr/>
+        </p:nvSpPr>
+        <p:spPr>
+          <a:xfrm>
+            <a:off x="320040" y="1828800"/>
+            <a:ext cx="548640" cy="347472"/>
+          </a:xfrm>
+          <a:prstGeom prst="rect">
+            <a:avLst/>
+          </a:prstGeom>
+          <a:noFill/>
+        </p:spPr>
+        <p:txBody>
+          <a:bodyPr wrap="square">
+            <a:spAutoFit/>
+          </a:bodyPr>
+          <a:lstStyle/>
+          <a:p>
+            <a:pPr algn="l"/>
+            <a:r>
+              <a:rPr sz="900" b="0" i="0">
+                <a:solidFill>
+                  <a:srgbClr val="FFFFFF"/>
+                </a:solidFill>
+              </a:rPr>
+              <a:t>← Top</a:t>
+            </a:r>
+          </a:p>
+        </p:txBody>
+      </p:sp>
+      <p:sp>
+        <p:nvSpPr>
+          <p:cNvPr id="16" name="Rectangle 15"/>
           <p:cNvSpPr/>
           <p:nvPr/>
         </p:nvSpPr>
@@ -17073,7 +17203,7 @@
       </p:sp>
       <p:sp>
         <p:nvSpPr>
-          <p:cNvPr id="15" name="TextBox 14"/>
+          <p:cNvPr id="17" name="TextBox 16"/>
           <p:cNvSpPr txBox="1"/>
           <p:nvPr/>
         </p:nvSpPr>
@@ -17107,7 +17237,7 @@
       </p:sp>
       <p:sp>
         <p:nvSpPr>
-          <p:cNvPr id="16" name="Rectangle 15"/>
+          <p:cNvPr id="18" name="Rectangle 17"/>
           <p:cNvSpPr/>
           <p:nvPr/>
         </p:nvSpPr>
@@ -17150,7 +17280,7 @@
       </p:sp>
       <p:sp>
         <p:nvSpPr>
-          <p:cNvPr id="17" name="TextBox 16"/>
+          <p:cNvPr id="19" name="TextBox 18"/>
           <p:cNvSpPr txBox="1"/>
           <p:nvPr/>
         </p:nvSpPr>
@@ -17184,7 +17314,7 @@
       </p:sp>
       <p:sp>
         <p:nvSpPr>
-          <p:cNvPr id="18" name="Rectangle 17"/>
+          <p:cNvPr id="20" name="Rectangle 19"/>
           <p:cNvSpPr/>
           <p:nvPr/>
         </p:nvSpPr>
@@ -17227,7 +17357,7 @@
       </p:sp>
       <p:sp>
         <p:nvSpPr>
-          <p:cNvPr id="19" name="TextBox 18"/>
+          <p:cNvPr id="21" name="TextBox 20"/>
           <p:cNvSpPr txBox="1"/>
           <p:nvPr/>
         </p:nvSpPr>
@@ -17261,7 +17391,7 @@
       </p:sp>
       <p:sp>
         <p:nvSpPr>
-          <p:cNvPr id="20" name="Rectangle 19"/>
+          <p:cNvPr id="22" name="Rectangle 21"/>
           <p:cNvSpPr/>
           <p:nvPr/>
         </p:nvSpPr>
@@ -17304,7 +17434,7 @@
       </p:sp>
       <p:sp>
         <p:nvSpPr>
-          <p:cNvPr id="21" name="TextBox 20"/>
+          <p:cNvPr id="23" name="TextBox 22"/>
           <p:cNvSpPr txBox="1"/>
           <p:nvPr/>
         </p:nvSpPr>
@@ -17338,7 +17468,7 @@
       </p:sp>
       <p:sp>
         <p:nvSpPr>
-          <p:cNvPr id="22" name="Rectangle 21"/>
+          <p:cNvPr id="24" name="Rectangle 23"/>
           <p:cNvSpPr/>
           <p:nvPr/>
         </p:nvSpPr>
@@ -17381,7 +17511,7 @@
       </p:sp>
       <p:sp>
         <p:nvSpPr>
-          <p:cNvPr id="23" name="Rectangle 22"/>
+          <p:cNvPr id="25" name="Rectangle 24"/>
           <p:cNvSpPr/>
           <p:nvPr/>
         </p:nvSpPr>
@@ -17424,7 +17554,7 @@
       </p:sp>
       <p:sp>
         <p:nvSpPr>
-          <p:cNvPr id="24" name="Rectangle 23"/>
+          <p:cNvPr id="26" name="Rectangle 25"/>
           <p:cNvSpPr/>
           <p:nvPr/>
         </p:nvSpPr>
@@ -17467,7 +17597,7 @@
       </p:sp>
       <p:sp>
         <p:nvSpPr>
-          <p:cNvPr id="25" name="Rectangle 24"/>
+          <p:cNvPr id="27" name="Rectangle 26"/>
           <p:cNvSpPr/>
           <p:nvPr/>
         </p:nvSpPr>
@@ -17510,7 +17640,7 @@
       </p:sp>
       <p:sp>
         <p:nvSpPr>
-          <p:cNvPr id="26" name="Rectangle 25"/>
+          <p:cNvPr id="28" name="Rectangle 27"/>
           <p:cNvSpPr/>
           <p:nvPr/>
         </p:nvSpPr>
@@ -17553,7 +17683,7 @@
       </p:sp>
       <p:sp>
         <p:nvSpPr>
-          <p:cNvPr id="27" name="Rectangle 26"/>
+          <p:cNvPr id="29" name="Rectangle 28"/>
           <p:cNvSpPr/>
           <p:nvPr/>
         </p:nvSpPr>
@@ -17596,7 +17726,7 @@
       </p:sp>
       <p:sp>
         <p:nvSpPr>
-          <p:cNvPr id="28" name="Rectangle 27"/>
+          <p:cNvPr id="30" name="Rectangle 29"/>
           <p:cNvSpPr/>
           <p:nvPr/>
         </p:nvSpPr>
@@ -17639,7 +17769,7 @@
       </p:sp>
       <p:sp>
         <p:nvSpPr>
-          <p:cNvPr id="29" name="Rectangle 28"/>
+          <p:cNvPr id="31" name="Rectangle 30"/>
           <p:cNvSpPr/>
           <p:nvPr/>
         </p:nvSpPr>
@@ -17682,7 +17812,7 @@
       </p:sp>
       <p:sp>
         <p:nvSpPr>
-          <p:cNvPr id="30" name="Rectangle 29"/>
+          <p:cNvPr id="32" name="Rectangle 31"/>
           <p:cNvSpPr/>
           <p:nvPr/>
         </p:nvSpPr>
@@ -17725,7 +17855,7 @@
       </p:sp>
       <p:sp>
         <p:nvSpPr>
-          <p:cNvPr id="31" name="Rectangle 30"/>
+          <p:cNvPr id="33" name="Rectangle 32"/>
           <p:cNvSpPr/>
           <p:nvPr/>
         </p:nvSpPr>
@@ -17768,7 +17898,7 @@
       </p:sp>
       <p:sp>
         <p:nvSpPr>
-          <p:cNvPr id="32" name="Rectangle 31"/>
+          <p:cNvPr id="34" name="Rectangle 33"/>
           <p:cNvSpPr/>
           <p:nvPr/>
         </p:nvSpPr>
@@ -17811,7 +17941,7 @@
       </p:sp>
       <p:sp>
         <p:nvSpPr>
-          <p:cNvPr id="33" name="Rectangle 32"/>
+          <p:cNvPr id="35" name="Rectangle 34"/>
           <p:cNvSpPr/>
           <p:nvPr/>
         </p:nvSpPr>
@@ -17854,7 +17984,7 @@
       </p:sp>
       <p:sp>
         <p:nvSpPr>
-          <p:cNvPr id="34" name="Rectangle 33"/>
+          <p:cNvPr id="36" name="Rectangle 35"/>
           <p:cNvSpPr/>
           <p:nvPr/>
         </p:nvSpPr>
@@ -17897,7 +18027,7 @@
       </p:sp>
       <p:sp>
         <p:nvSpPr>
-          <p:cNvPr id="35" name="Rectangle 34"/>
+          <p:cNvPr id="37" name="Rectangle 36"/>
           <p:cNvSpPr/>
           <p:nvPr/>
         </p:nvSpPr>
@@ -17940,7 +18070,7 @@
       </p:sp>
       <p:sp>
         <p:nvSpPr>
-          <p:cNvPr id="36" name="Rectangle 35"/>
+          <p:cNvPr id="38" name="Rectangle 37"/>
           <p:cNvSpPr/>
           <p:nvPr/>
         </p:nvSpPr>
@@ -17983,7 +18113,7 @@
       </p:sp>
       <p:sp>
         <p:nvSpPr>
-          <p:cNvPr id="37" name="TextBox 36"/>
+          <p:cNvPr id="39" name="TextBox 38"/>
           <p:cNvSpPr txBox="1"/>
           <p:nvPr/>
         </p:nvSpPr>
@@ -18018,7 +18148,7 @@
       </p:sp>
       <p:sp>
         <p:nvSpPr>
-          <p:cNvPr id="38" name="TextBox 37"/>
+          <p:cNvPr id="40" name="TextBox 39"/>
           <p:cNvSpPr txBox="1"/>
           <p:nvPr/>
         </p:nvSpPr>
@@ -18053,7 +18183,7 @@
       </p:sp>
       <p:sp>
         <p:nvSpPr>
-          <p:cNvPr id="39" name="TextBox 38"/>
+          <p:cNvPr id="41" name="TextBox 40"/>
           <p:cNvSpPr txBox="1"/>
           <p:nvPr/>
         </p:nvSpPr>
@@ -18091,7 +18221,7 @@
       </p:sp>
       <p:sp>
         <p:nvSpPr>
-          <p:cNvPr id="40" name="Rectangle 39"/>
+          <p:cNvPr id="42" name="Rectangle 41"/>
           <p:cNvSpPr/>
           <p:nvPr/>
         </p:nvSpPr>
@@ -18134,7 +18264,7 @@
       </p:sp>
       <p:sp>
         <p:nvSpPr>
-          <p:cNvPr id="41" name="TextBox 40"/>
+          <p:cNvPr id="43" name="TextBox 42"/>
           <p:cNvSpPr txBox="1"/>
           <p:nvPr/>
         </p:nvSpPr>
@@ -18168,7 +18298,7 @@
       </p:sp>
       <p:sp>
         <p:nvSpPr>
-          <p:cNvPr id="42" name="Rectangle 41"/>
+          <p:cNvPr id="44" name="Rectangle 43"/>
           <p:cNvSpPr/>
           <p:nvPr/>
         </p:nvSpPr>
@@ -18211,7 +18341,7 @@
       </p:sp>
       <p:sp>
         <p:nvSpPr>
-          <p:cNvPr id="43" name="TextBox 42"/>
+          <p:cNvPr id="45" name="TextBox 44"/>
           <p:cNvSpPr txBox="1"/>
           <p:nvPr/>
         </p:nvSpPr>
@@ -18245,7 +18375,7 @@
       </p:sp>
       <p:sp>
         <p:nvSpPr>
-          <p:cNvPr id="44" name="TextBox 43"/>
+          <p:cNvPr id="46" name="TextBox 45"/>
           <p:cNvSpPr txBox="1"/>
           <p:nvPr/>
         </p:nvSpPr>
@@ -18279,7 +18409,7 @@
       </p:sp>
       <p:sp>
         <p:nvSpPr>
-          <p:cNvPr id="45" name="TextBox 44"/>
+          <p:cNvPr id="47" name="TextBox 46"/>
           <p:cNvSpPr txBox="1"/>
           <p:nvPr/>
         </p:nvSpPr>
@@ -18313,7 +18443,7 @@
       </p:sp>
       <p:sp>
         <p:nvSpPr>
-          <p:cNvPr id="46" name="TextBox 45"/>
+          <p:cNvPr id="48" name="TextBox 47"/>
           <p:cNvSpPr txBox="1"/>
           <p:nvPr/>
         </p:nvSpPr>
@@ -18347,7 +18477,7 @@
       </p:sp>
       <p:sp>
         <p:nvSpPr>
-          <p:cNvPr id="47" name="TextBox 46"/>
+          <p:cNvPr id="49" name="TextBox 48"/>
           <p:cNvSpPr txBox="1"/>
           <p:nvPr/>
         </p:nvSpPr>
@@ -18381,7 +18511,7 @@
       </p:sp>
       <p:sp>
         <p:nvSpPr>
-          <p:cNvPr id="48" name="TextBox 47"/>
+          <p:cNvPr id="50" name="TextBox 49"/>
           <p:cNvSpPr txBox="1"/>
           <p:nvPr/>
         </p:nvSpPr>
@@ -18415,7 +18545,7 @@
       </p:sp>
       <p:sp>
         <p:nvSpPr>
-          <p:cNvPr id="49" name="TextBox 48"/>
+          <p:cNvPr id="51" name="TextBox 50"/>
           <p:cNvSpPr txBox="1"/>
           <p:nvPr/>
         </p:nvSpPr>
@@ -18449,7 +18579,7 @@
       </p:sp>
       <p:sp>
         <p:nvSpPr>
-          <p:cNvPr id="50" name="Rectangle 49"/>
+          <p:cNvPr id="52" name="Rectangle 51"/>
           <p:cNvSpPr/>
           <p:nvPr/>
         </p:nvSpPr>
@@ -18492,7 +18622,7 @@
       </p:sp>
       <p:sp>
         <p:nvSpPr>
-          <p:cNvPr id="51" name="Rectangle 50"/>
+          <p:cNvPr id="53" name="Rectangle 52"/>
           <p:cNvSpPr/>
           <p:nvPr/>
         </p:nvSpPr>
@@ -18535,7 +18665,7 @@
       </p:sp>
       <p:sp>
         <p:nvSpPr>
-          <p:cNvPr id="52" name="Rectangle 51"/>
+          <p:cNvPr id="54" name="Rectangle 53"/>
           <p:cNvSpPr/>
           <p:nvPr/>
         </p:nvSpPr>
@@ -18578,7 +18708,7 @@
       </p:sp>
       <p:sp>
         <p:nvSpPr>
-          <p:cNvPr id="53" name="Rectangle 52"/>
+          <p:cNvPr id="55" name="Rectangle 54"/>
           <p:cNvSpPr/>
           <p:nvPr/>
         </p:nvSpPr>
@@ -18621,7 +18751,7 @@
       </p:sp>
       <p:sp>
         <p:nvSpPr>
-          <p:cNvPr id="54" name="TextBox 53"/>
+          <p:cNvPr id="56" name="TextBox 55"/>
           <p:cNvSpPr txBox="1"/>
           <p:nvPr/>
         </p:nvSpPr>

</xml_diff>